<commit_message>
Sync all released folders (pdfs=true)
</commit_message>
<xml_diff>
--- a/instructor/presentations/ppts/instructor.pptx
+++ b/instructor/presentations/ppts/instructor.pptx
@@ -4416,6 +4416,66 @@
           </a:p>
         </p:txBody>
       </p:sp>
+      <p:pic>
+        <p:nvPicPr>
+          <p:cNvPr descr="/home/runner/work/Expeditors_TPM_private/Expeditors_TPM_private/instructor/assets/avatar.jpg" id="0" name="Picture 1"/>
+          <p:cNvPicPr>
+            <a:picLocks noGrp="1" noChangeAspect="1"/>
+          </p:cNvPicPr>
+          <p:nvPr/>
+        </p:nvPicPr>
+        <p:blipFill>
+          <a:blip r:embed="rId3"/>
+          <a:stretch>
+            <a:fillRect/>
+          </a:stretch>
+        </p:blipFill>
+        <p:spPr bwMode="auto">
+          <a:xfrm>
+            <a:off x="3124200" y="1193800"/>
+            <a:ext cx="2882900" cy="2882900"/>
+          </a:xfrm>
+          <a:prstGeom prst="rect">
+            <a:avLst/>
+          </a:prstGeom>
+          <a:noFill/>
+          <a:ln w="9525">
+            <a:noFill/>
+            <a:headEnd/>
+            <a:tailEnd/>
+          </a:ln>
+        </p:spPr>
+      </p:pic>
+      <p:sp>
+        <p:nvSpPr>
+          <p:cNvPr id="1" name="TextBox 3"/>
+          <p:cNvSpPr txBox="1"/>
+          <p:nvPr/>
+        </p:nvSpPr>
+        <p:spPr>
+          <a:xfrm>
+            <a:off x="457200" y="4076700"/>
+            <a:ext cx="8229600" cy="508000"/>
+          </a:xfrm>
+          <a:prstGeom prst="rect">
+            <a:avLst/>
+          </a:prstGeom>
+          <a:noFill/>
+        </p:spPr>
+        <p:txBody>
+          <a:bodyPr/>
+          <a:lstStyle/>
+          <a:p>
+            <a:pPr lvl="0" indent="0" marL="0" algn="ctr">
+              <a:buNone/>
+            </a:pPr>
+            <a:r>
+              <a:rPr/>
+              <a:t>John Kidd</a:t>
+            </a:r>
+          </a:p>
+        </p:txBody>
+      </p:sp>
       <p:sp>
         <p:nvSpPr>
           <p:cNvPr id="3" name="Content Placeholder 2"/>
@@ -4430,11 +4490,6 @@
         <p:txBody>
           <a:bodyPr/>
           <a:lstStyle/>
-          <a:p>
-            <a:pPr lvl="0" indent="0" marL="0">
-              <a:buNone/>
-            </a:pPr>
-          </a:p>
           <a:p>
             <a:pPr lvl="0" indent="0" marL="0">
               <a:spcBef>

</xml_diff>